<commit_message>
feat: complete Sprint 34 guided research workspace
</commit_message>
<xml_diff>
--- a/output/presentation/SignalForge-Judge-Deck.pptx
+++ b/output/presentation/SignalForge-Judge-Deck.pptx
@@ -2,116 +2,21 @@
 <file path=ppt/presentation.xml><?xml version="1.0" encoding="utf-8"?>
 <p:presentation xmlns:p="http://schemas.openxmlformats.org/presentationml/2006/main">
   <p:sldMasterIdLst>
-    <p:sldMasterId xmlns:r="http://schemas.openxmlformats.org/officeDocument/2006/relationships" id="2147483648" r:id="Racd7f8b736cb4166"/>
+    <p:sldMasterId xmlns:r="http://schemas.openxmlformats.org/officeDocument/2006/relationships" id="2147483648" r:id="R019c2f26a75247cb"/>
   </p:sldMasterIdLst>
   <p:notesMasterIdLst>
-    <p:notesMasterId xmlns:r="http://schemas.openxmlformats.org/officeDocument/2006/relationships" r:id="Rf7a2973ff5f74b5b"/>
+    <p:notesMasterId xmlns:r="http://schemas.openxmlformats.org/officeDocument/2006/relationships" r:id="Raef91185217a4883"/>
   </p:notesMasterIdLst>
   <p:sldIdLst>
-    <p:sldId xmlns:r="http://schemas.openxmlformats.org/officeDocument/2006/relationships" id="256" r:id="R4af7cd7f84d74b9e"/>
-    <p:sldId xmlns:r="http://schemas.openxmlformats.org/officeDocument/2006/relationships" id="257" r:id="R2bee876782be4a57"/>
-    <p:sldId xmlns:r="http://schemas.openxmlformats.org/officeDocument/2006/relationships" id="258" r:id="R9513c9d20d4a4f8d"/>
-    <p:sldId xmlns:r="http://schemas.openxmlformats.org/officeDocument/2006/relationships" id="259" r:id="R4229efda333a414e"/>
-    <p:sldId xmlns:r="http://schemas.openxmlformats.org/officeDocument/2006/relationships" id="260" r:id="R9eee7e6c1234452a"/>
-    <p:sldId xmlns:r="http://schemas.openxmlformats.org/officeDocument/2006/relationships" id="261" r:id="R5cd92d14177c4321"/>
+    <p:sldId xmlns:r="http://schemas.openxmlformats.org/officeDocument/2006/relationships" id="256" r:id="R175dca391be34a98"/>
+    <p:sldId xmlns:r="http://schemas.openxmlformats.org/officeDocument/2006/relationships" id="257" r:id="R1b01041426ff42bb"/>
+    <p:sldId xmlns:r="http://schemas.openxmlformats.org/officeDocument/2006/relationships" id="258" r:id="R0bc27265310446ef"/>
+    <p:sldId xmlns:r="http://schemas.openxmlformats.org/officeDocument/2006/relationships" id="259" r:id="Re51853a91cab497c"/>
+    <p:sldId xmlns:r="http://schemas.openxmlformats.org/officeDocument/2006/relationships" id="260" r:id="R7696d42331e940ca"/>
+    <p:sldId xmlns:r="http://schemas.openxmlformats.org/officeDocument/2006/relationships" id="261" r:id="Re11337ac353e4e1a"/>
   </p:sldIdLst>
   <p:sldSz cx="12192000" cy="6858000"/>
   <p:notesSz cx="6858000" cy="9144000"/>
-  <p:defaultTextStyle>
-    <a:defPPr xmlns:a="http://schemas.openxmlformats.org/drawingml/2006/main">
-      <a:defRPr lang="en-US"/>
-    </a:defPPr>
-    <a:lvl1pPr xmlns:a="http://schemas.openxmlformats.org/drawingml/2006/main" marL="0" indent="0" algn="l" defTabSz="914400">
-      <a:defRPr sz="1800" kern="1200">
-        <a:solidFill>
-          <a:schemeClr val="tx1"/>
-        </a:solidFill>
-        <a:latin typeface="+mn-lt"/>
-        <a:ea typeface="+mn-ea"/>
-        <a:cs typeface="+mn-cs"/>
-      </a:defRPr>
-    </a:lvl1pPr>
-    <a:lvl2pPr xmlns:a="http://schemas.openxmlformats.org/drawingml/2006/main" marL="457200" indent="0" algn="l" defTabSz="914400">
-      <a:defRPr sz="1800" kern="1200">
-        <a:solidFill>
-          <a:schemeClr val="tx1"/>
-        </a:solidFill>
-        <a:latin typeface="+mn-lt"/>
-        <a:ea typeface="+mn-ea"/>
-        <a:cs typeface="+mn-cs"/>
-      </a:defRPr>
-    </a:lvl2pPr>
-    <a:lvl3pPr xmlns:a="http://schemas.openxmlformats.org/drawingml/2006/main" marL="914400" indent="0" algn="l" defTabSz="914400">
-      <a:defRPr sz="1800" kern="1200">
-        <a:solidFill>
-          <a:schemeClr val="tx1"/>
-        </a:solidFill>
-        <a:latin typeface="+mn-lt"/>
-        <a:ea typeface="+mn-ea"/>
-        <a:cs typeface="+mn-cs"/>
-      </a:defRPr>
-    </a:lvl3pPr>
-    <a:lvl4pPr xmlns:a="http://schemas.openxmlformats.org/drawingml/2006/main" marL="1371600" indent="0" algn="l" defTabSz="914400">
-      <a:defRPr sz="1800" kern="1200">
-        <a:solidFill>
-          <a:schemeClr val="tx1"/>
-        </a:solidFill>
-        <a:latin typeface="+mn-lt"/>
-        <a:ea typeface="+mn-ea"/>
-        <a:cs typeface="+mn-cs"/>
-      </a:defRPr>
-    </a:lvl4pPr>
-    <a:lvl5pPr xmlns:a="http://schemas.openxmlformats.org/drawingml/2006/main" marL="1828800" indent="0" algn="l" defTabSz="914400">
-      <a:defRPr sz="1800" kern="1200">
-        <a:solidFill>
-          <a:schemeClr val="tx1"/>
-        </a:solidFill>
-        <a:latin typeface="+mn-lt"/>
-        <a:ea typeface="+mn-ea"/>
-        <a:cs typeface="+mn-cs"/>
-      </a:defRPr>
-    </a:lvl5pPr>
-    <a:lvl6pPr xmlns:a="http://schemas.openxmlformats.org/drawingml/2006/main" marL="2286000" indent="0" algn="l" defTabSz="914400">
-      <a:defRPr sz="1800" kern="1200">
-        <a:solidFill>
-          <a:schemeClr val="tx1"/>
-        </a:solidFill>
-        <a:latin typeface="+mn-lt"/>
-        <a:ea typeface="+mn-ea"/>
-        <a:cs typeface="+mn-cs"/>
-      </a:defRPr>
-    </a:lvl6pPr>
-    <a:lvl7pPr xmlns:a="http://schemas.openxmlformats.org/drawingml/2006/main" marL="2743200" indent="0" algn="l" defTabSz="914400">
-      <a:defRPr sz="1800" kern="1200">
-        <a:solidFill>
-          <a:schemeClr val="tx1"/>
-        </a:solidFill>
-        <a:latin typeface="+mn-lt"/>
-        <a:ea typeface="+mn-ea"/>
-        <a:cs typeface="+mn-cs"/>
-      </a:defRPr>
-    </a:lvl7pPr>
-    <a:lvl8pPr xmlns:a="http://schemas.openxmlformats.org/drawingml/2006/main" marL="3200400" indent="0" algn="l" defTabSz="914400">
-      <a:defRPr sz="1800" kern="1200">
-        <a:solidFill>
-          <a:schemeClr val="tx1"/>
-        </a:solidFill>
-        <a:latin typeface="+mn-lt"/>
-        <a:ea typeface="+mn-ea"/>
-        <a:cs typeface="+mn-cs"/>
-      </a:defRPr>
-    </a:lvl8pPr>
-    <a:lvl9pPr xmlns:a="http://schemas.openxmlformats.org/drawingml/2006/main" marL="3657600" indent="0" algn="l" defTabSz="914400">
-      <a:defRPr sz="1800" kern="1200">
-        <a:solidFill>
-          <a:schemeClr val="tx1"/>
-        </a:solidFill>
-        <a:latin typeface="+mn-lt"/>
-        <a:ea typeface="+mn-ea"/>
-        <a:cs typeface="+mn-cs"/>
-      </a:defRPr>
-    </a:lvl9pPr>
-  </p:defaultTextStyle>
 </p:presentation>
 </file>
 
@@ -936,7 +841,7 @@
   </p:cSld>
   <p:clrMap bg1="lt1" tx1="dk1" bg2="lt2" tx2="dk2" accent1="accent1" accent2="accent2" accent3="accent3" accent4="accent4" accent5="accent5" accent6="accent6" hlink="hlink" folHlink="folHlink"/>
   <p:sldLayoutIdLst>
-    <p:sldLayoutId xmlns:r="http://schemas.openxmlformats.org/officeDocument/2006/relationships" id="2147483649" r:id="R7dd8e2e43dec4c53"/>
+    <p:sldLayoutId xmlns:r="http://schemas.openxmlformats.org/officeDocument/2006/relationships" id="2147483649" r:id="Rbc681ff179a6495d"/>
   </p:sldLayoutIdLst>
   <p:txStyles>
     <p:titleStyle>
@@ -1719,6 +1624,7 @@
           <a:lstStyle xmlns:a="http://schemas.openxmlformats.org/drawingml/2006/main"/>
           <a:p xmlns:a="http://schemas.openxmlformats.org/drawingml/2006/main">
             <a:pPr algn="l">
+              <a:buNone/>
               <a:defRPr sz="5100" b="1">
                 <a:solidFill>
                   <a:srgbClr val="FFFFFF"/>
@@ -1769,6 +1675,7 @@
           <a:lstStyle xmlns:a="http://schemas.openxmlformats.org/drawingml/2006/main"/>
           <a:p xmlns:a="http://schemas.openxmlformats.org/drawingml/2006/main">
             <a:pPr algn="l">
+              <a:buNone/>
               <a:defRPr sz="2625" b="1">
                 <a:solidFill>
                   <a:srgbClr val="DCEAE4"/>
@@ -1786,6 +1693,7 @@
           </a:p>
           <a:p xmlns:a="http://schemas.openxmlformats.org/drawingml/2006/main">
             <a:pPr algn="l">
+              <a:buNone/>
               <a:defRPr sz="2625" b="1">
                 <a:solidFill>
                   <a:srgbClr val="DCEAE4"/>
@@ -1836,6 +1744,7 @@
           <a:lstStyle xmlns:a="http://schemas.openxmlformats.org/drawingml/2006/main"/>
           <a:p xmlns:a="http://schemas.openxmlformats.org/drawingml/2006/main">
             <a:pPr algn="l">
+              <a:buNone/>
               <a:defRPr sz="1575" b="0">
                 <a:solidFill>
                   <a:srgbClr val="BFD6D0"/>
@@ -1886,6 +1795,7 @@
           <a:lstStyle xmlns:a="http://schemas.openxmlformats.org/drawingml/2006/main"/>
           <a:p xmlns:a="http://schemas.openxmlformats.org/drawingml/2006/main">
             <a:pPr algn="l">
+              <a:buNone/>
               <a:defRPr sz="1050" b="0">
                 <a:solidFill>
                   <a:srgbClr val="8EB3AB"/>
@@ -1969,6 +1879,7 @@
           <a:lstStyle xmlns:a="http://schemas.openxmlformats.org/drawingml/2006/main"/>
           <a:p xmlns:a="http://schemas.openxmlformats.org/drawingml/2006/main">
             <a:pPr algn="ctr">
+              <a:buNone/>
               <a:defRPr sz="1350" b="1">
                 <a:solidFill>
                   <a:srgbClr val="102C38"/>
@@ -1986,6 +1897,7 @@
           </a:p>
           <a:p xmlns:a="http://schemas.openxmlformats.org/drawingml/2006/main">
             <a:pPr algn="ctr">
+              <a:buNone/>
               <a:defRPr sz="1350" b="1">
                 <a:solidFill>
                   <a:srgbClr val="102C38"/>
@@ -2065,6 +1977,7 @@
           <a:lstStyle xmlns:a="http://schemas.openxmlformats.org/drawingml/2006/main"/>
           <a:p xmlns:a="http://schemas.openxmlformats.org/drawingml/2006/main">
             <a:pPr algn="l">
+              <a:buNone/>
               <a:defRPr sz="975" b="1">
                 <a:solidFill>
                   <a:srgbClr val="C97936"/>
@@ -2115,6 +2028,7 @@
           <a:lstStyle xmlns:a="http://schemas.openxmlformats.org/drawingml/2006/main"/>
           <a:p xmlns:a="http://schemas.openxmlformats.org/drawingml/2006/main">
             <a:pPr algn="l">
+              <a:buNone/>
               <a:defRPr sz="3000" b="1">
                 <a:solidFill>
                   <a:srgbClr val="102C38"/>
@@ -2196,6 +2110,7 @@
           <a:lstStyle xmlns:a="http://schemas.openxmlformats.org/drawingml/2006/main"/>
           <a:p xmlns:a="http://schemas.openxmlformats.org/drawingml/2006/main">
             <a:pPr algn="l">
+              <a:buNone/>
               <a:defRPr sz="825" b="0">
                 <a:solidFill>
                   <a:srgbClr val="6A7D80"/>
@@ -2246,6 +2161,7 @@
           <a:lstStyle xmlns:a="http://schemas.openxmlformats.org/drawingml/2006/main"/>
           <a:p xmlns:a="http://schemas.openxmlformats.org/drawingml/2006/main">
             <a:pPr algn="r">
+              <a:buNone/>
               <a:defRPr sz="825" b="0">
                 <a:solidFill>
                   <a:srgbClr val="6A7D80"/>
@@ -2296,6 +2212,7 @@
           <a:lstStyle xmlns:a="http://schemas.openxmlformats.org/drawingml/2006/main"/>
           <a:p xmlns:a="http://schemas.openxmlformats.org/drawingml/2006/main">
             <a:pPr algn="l">
+              <a:buNone/>
               <a:defRPr sz="2400" b="1">
                 <a:solidFill>
                   <a:srgbClr val="102C38"/>
@@ -2313,6 +2230,7 @@
           </a:p>
           <a:p xmlns:a="http://schemas.openxmlformats.org/drawingml/2006/main">
             <a:pPr algn="l">
+              <a:buNone/>
               <a:defRPr sz="2400" b="1">
                 <a:solidFill>
                   <a:srgbClr val="102C38"/>
@@ -2363,6 +2281,7 @@
           <a:lstStyle xmlns:a="http://schemas.openxmlformats.org/drawingml/2006/main"/>
           <a:p xmlns:a="http://schemas.openxmlformats.org/drawingml/2006/main">
             <a:pPr algn="l">
+              <a:buNone/>
               <a:defRPr sz="1425" b="0">
                 <a:solidFill>
                   <a:srgbClr val="334B52"/>
@@ -2448,6 +2367,7 @@
           <a:lstStyle xmlns:a="http://schemas.openxmlformats.org/drawingml/2006/main"/>
           <a:p xmlns:a="http://schemas.openxmlformats.org/drawingml/2006/main">
             <a:pPr algn="l">
+              <a:buNone/>
               <a:defRPr sz="1050" b="1">
                 <a:solidFill>
                   <a:srgbClr val="C97936"/>
@@ -2498,6 +2418,7 @@
           <a:lstStyle xmlns:a="http://schemas.openxmlformats.org/drawingml/2006/main"/>
           <a:p xmlns:a="http://schemas.openxmlformats.org/drawingml/2006/main">
             <a:pPr algn="l">
+              <a:buNone/>
               <a:defRPr sz="1500" b="1">
                 <a:solidFill>
                   <a:srgbClr val="102C38"/>
@@ -2579,6 +2500,7 @@
           <a:lstStyle xmlns:a="http://schemas.openxmlformats.org/drawingml/2006/main"/>
           <a:p xmlns:a="http://schemas.openxmlformats.org/drawingml/2006/main">
             <a:pPr algn="l">
+              <a:buNone/>
               <a:defRPr sz="1050" b="1">
                 <a:solidFill>
                   <a:srgbClr val="C97936"/>
@@ -2629,6 +2551,7 @@
           <a:lstStyle xmlns:a="http://schemas.openxmlformats.org/drawingml/2006/main"/>
           <a:p xmlns:a="http://schemas.openxmlformats.org/drawingml/2006/main">
             <a:pPr algn="l">
+              <a:buNone/>
               <a:defRPr sz="1500" b="1">
                 <a:solidFill>
                   <a:srgbClr val="102C38"/>
@@ -2710,6 +2633,7 @@
           <a:lstStyle xmlns:a="http://schemas.openxmlformats.org/drawingml/2006/main"/>
           <a:p xmlns:a="http://schemas.openxmlformats.org/drawingml/2006/main">
             <a:pPr algn="l">
+              <a:buNone/>
               <a:defRPr sz="1050" b="1">
                 <a:solidFill>
                   <a:srgbClr val="C97936"/>
@@ -2760,6 +2684,7 @@
           <a:lstStyle xmlns:a="http://schemas.openxmlformats.org/drawingml/2006/main"/>
           <a:p xmlns:a="http://schemas.openxmlformats.org/drawingml/2006/main">
             <a:pPr algn="l">
+              <a:buNone/>
               <a:defRPr sz="1500" b="1">
                 <a:solidFill>
                   <a:srgbClr val="102C38"/>
@@ -2841,6 +2766,7 @@
           <a:lstStyle xmlns:a="http://schemas.openxmlformats.org/drawingml/2006/main"/>
           <a:p xmlns:a="http://schemas.openxmlformats.org/drawingml/2006/main">
             <a:pPr algn="l">
+              <a:buNone/>
               <a:defRPr sz="1050" b="1">
                 <a:solidFill>
                   <a:srgbClr val="C97936"/>
@@ -2891,6 +2817,7 @@
           <a:lstStyle xmlns:a="http://schemas.openxmlformats.org/drawingml/2006/main"/>
           <a:p xmlns:a="http://schemas.openxmlformats.org/drawingml/2006/main">
             <a:pPr algn="l">
+              <a:buNone/>
               <a:defRPr sz="1500" b="1">
                 <a:solidFill>
                   <a:srgbClr val="102C38"/>
@@ -2941,6 +2868,7 @@
           <a:lstStyle xmlns:a="http://schemas.openxmlformats.org/drawingml/2006/main"/>
           <a:p xmlns:a="http://schemas.openxmlformats.org/drawingml/2006/main">
             <a:pPr algn="l">
+              <a:buNone/>
               <a:defRPr sz="1200" b="1">
                 <a:solidFill>
                   <a:srgbClr val="3F756E"/>
@@ -3020,6 +2948,7 @@
           <a:lstStyle xmlns:a="http://schemas.openxmlformats.org/drawingml/2006/main"/>
           <a:p xmlns:a="http://schemas.openxmlformats.org/drawingml/2006/main">
             <a:pPr algn="l">
+              <a:buNone/>
               <a:defRPr sz="975" b="1">
                 <a:solidFill>
                   <a:srgbClr val="C97936"/>
@@ -3070,6 +2999,7 @@
           <a:lstStyle xmlns:a="http://schemas.openxmlformats.org/drawingml/2006/main"/>
           <a:p xmlns:a="http://schemas.openxmlformats.org/drawingml/2006/main">
             <a:pPr algn="l">
+              <a:buNone/>
               <a:defRPr sz="3000" b="1">
                 <a:solidFill>
                   <a:srgbClr val="102C38"/>
@@ -3151,6 +3081,7 @@
           <a:lstStyle xmlns:a="http://schemas.openxmlformats.org/drawingml/2006/main"/>
           <a:p xmlns:a="http://schemas.openxmlformats.org/drawingml/2006/main">
             <a:pPr algn="l">
+              <a:buNone/>
               <a:defRPr sz="825" b="0">
                 <a:solidFill>
                   <a:srgbClr val="6A7D80"/>
@@ -3201,6 +3132,7 @@
           <a:lstStyle xmlns:a="http://schemas.openxmlformats.org/drawingml/2006/main"/>
           <a:p xmlns:a="http://schemas.openxmlformats.org/drawingml/2006/main">
             <a:pPr algn="r">
+              <a:buNone/>
               <a:defRPr sz="825" b="0">
                 <a:solidFill>
                   <a:srgbClr val="6A7D80"/>
@@ -3282,6 +3214,7 @@
           <a:lstStyle xmlns:a="http://schemas.openxmlformats.org/drawingml/2006/main"/>
           <a:p xmlns:a="http://schemas.openxmlformats.org/drawingml/2006/main">
             <a:pPr algn="l">
+              <a:buNone/>
               <a:defRPr sz="975" b="1">
                 <a:solidFill>
                   <a:srgbClr val="C97936"/>
@@ -3301,14 +3234,14 @@
       </p:sp>
       <p:pic>
         <p:nvPicPr>
-          <p:cNvPr id="17" name=""/>
+          <p:cNvPr id="19" name=""/>
           <p:cNvPicPr>
             <a:picLocks xmlns:a="http://schemas.openxmlformats.org/drawingml/2006/main" noChangeAspect="1"/>
           </p:cNvPicPr>
           <p:nvPr/>
         </p:nvPicPr>
         <p:blipFill>
-          <a:blip xmlns:r="http://schemas.openxmlformats.org/officeDocument/2006/relationships" xmlns:a="http://schemas.openxmlformats.org/drawingml/2006/main" r:embed="Rfb578cb226434d36"/>
+          <a:blip xmlns:r="http://schemas.openxmlformats.org/officeDocument/2006/relationships" xmlns:a="http://schemas.openxmlformats.org/drawingml/2006/main" r:embed="Rd9d3ebfa54434e08"/>
           <a:stretch xmlns:a="http://schemas.openxmlformats.org/drawingml/2006/main"/>
         </p:blipFill>
         <p:spPr>
@@ -3354,6 +3287,7 @@
           <a:lstStyle xmlns:a="http://schemas.openxmlformats.org/drawingml/2006/main"/>
           <a:p xmlns:a="http://schemas.openxmlformats.org/drawingml/2006/main">
             <a:pPr algn="ctr">
+              <a:buNone/>
               <a:defRPr sz="1200" b="1">
                 <a:solidFill>
                   <a:srgbClr val="3F756E"/>
@@ -3433,6 +3367,7 @@
           <a:lstStyle xmlns:a="http://schemas.openxmlformats.org/drawingml/2006/main"/>
           <a:p xmlns:a="http://schemas.openxmlformats.org/drawingml/2006/main">
             <a:pPr algn="l">
+              <a:buNone/>
               <a:defRPr sz="975" b="1">
                 <a:solidFill>
                   <a:srgbClr val="C97936"/>
@@ -3483,6 +3418,7 @@
           <a:lstStyle xmlns:a="http://schemas.openxmlformats.org/drawingml/2006/main"/>
           <a:p xmlns:a="http://schemas.openxmlformats.org/drawingml/2006/main">
             <a:pPr algn="l">
+              <a:buNone/>
               <a:defRPr sz="3000" b="1">
                 <a:solidFill>
                   <a:srgbClr val="102C38"/>
@@ -3564,6 +3500,7 @@
           <a:lstStyle xmlns:a="http://schemas.openxmlformats.org/drawingml/2006/main"/>
           <a:p xmlns:a="http://schemas.openxmlformats.org/drawingml/2006/main">
             <a:pPr algn="l">
+              <a:buNone/>
               <a:defRPr sz="825" b="0">
                 <a:solidFill>
                   <a:srgbClr val="6A7D80"/>
@@ -3614,6 +3551,7 @@
           <a:lstStyle xmlns:a="http://schemas.openxmlformats.org/drawingml/2006/main"/>
           <a:p xmlns:a="http://schemas.openxmlformats.org/drawingml/2006/main">
             <a:pPr algn="r">
+              <a:buNone/>
               <a:defRPr sz="825" b="0">
                 <a:solidFill>
                   <a:srgbClr val="6A7D80"/>
@@ -3695,6 +3633,7 @@
           <a:lstStyle xmlns:a="http://schemas.openxmlformats.org/drawingml/2006/main"/>
           <a:p xmlns:a="http://schemas.openxmlformats.org/drawingml/2006/main">
             <a:pPr algn="ctr">
+              <a:buNone/>
               <a:defRPr sz="1200" b="1">
                 <a:solidFill>
                   <a:srgbClr val="FFFFFF"/>
@@ -3745,6 +3684,7 @@
           <a:lstStyle xmlns:a="http://schemas.openxmlformats.org/drawingml/2006/main"/>
           <a:p xmlns:a="http://schemas.openxmlformats.org/drawingml/2006/main">
             <a:pPr algn="l">
+              <a:buNone/>
               <a:defRPr sz="1650" b="1">
                 <a:solidFill>
                   <a:srgbClr val="102C38"/>
@@ -3795,6 +3735,7 @@
           <a:lstStyle xmlns:a="http://schemas.openxmlformats.org/drawingml/2006/main"/>
           <a:p xmlns:a="http://schemas.openxmlformats.org/drawingml/2006/main">
             <a:pPr algn="l">
+              <a:buNone/>
               <a:defRPr sz="1125" b="0">
                 <a:solidFill>
                   <a:srgbClr val="6A7D80"/>
@@ -3876,6 +3817,7 @@
           <a:lstStyle xmlns:a="http://schemas.openxmlformats.org/drawingml/2006/main"/>
           <a:p xmlns:a="http://schemas.openxmlformats.org/drawingml/2006/main">
             <a:pPr algn="ctr">
+              <a:buNone/>
               <a:defRPr sz="1200" b="1">
                 <a:solidFill>
                   <a:srgbClr val="FFFFFF"/>
@@ -3926,6 +3868,7 @@
           <a:lstStyle xmlns:a="http://schemas.openxmlformats.org/drawingml/2006/main"/>
           <a:p xmlns:a="http://schemas.openxmlformats.org/drawingml/2006/main">
             <a:pPr algn="l">
+              <a:buNone/>
               <a:defRPr sz="1650" b="1">
                 <a:solidFill>
                   <a:srgbClr val="102C38"/>
@@ -3976,6 +3919,7 @@
           <a:lstStyle xmlns:a="http://schemas.openxmlformats.org/drawingml/2006/main"/>
           <a:p xmlns:a="http://schemas.openxmlformats.org/drawingml/2006/main">
             <a:pPr algn="l">
+              <a:buNone/>
               <a:defRPr sz="1125" b="0">
                 <a:solidFill>
                   <a:srgbClr val="6A7D80"/>
@@ -3988,7 +3932,7 @@
                   <a:srgbClr val="6A7D80"/>
                 </a:solidFill>
               </a:rPr>
-              <a:t>28 role-authorized deterministic operations</a:t>
+              <a:t>80 role-authorized deterministic operations</a:t>
             </a:r>
           </a:p>
         </p:txBody>
@@ -4057,6 +4001,7 @@
           <a:lstStyle xmlns:a="http://schemas.openxmlformats.org/drawingml/2006/main"/>
           <a:p xmlns:a="http://schemas.openxmlformats.org/drawingml/2006/main">
             <a:pPr algn="ctr">
+              <a:buNone/>
               <a:defRPr sz="1200" b="1">
                 <a:solidFill>
                   <a:srgbClr val="FFFFFF"/>
@@ -4107,6 +4052,7 @@
           <a:lstStyle xmlns:a="http://schemas.openxmlformats.org/drawingml/2006/main"/>
           <a:p xmlns:a="http://schemas.openxmlformats.org/drawingml/2006/main">
             <a:pPr algn="l">
+              <a:buNone/>
               <a:defRPr sz="1650" b="1">
                 <a:solidFill>
                   <a:srgbClr val="102C38"/>
@@ -4157,6 +4103,7 @@
           <a:lstStyle xmlns:a="http://schemas.openxmlformats.org/drawingml/2006/main"/>
           <a:p xmlns:a="http://schemas.openxmlformats.org/drawingml/2006/main">
             <a:pPr algn="l">
+              <a:buNone/>
               <a:defRPr sz="1125" b="0">
                 <a:solidFill>
                   <a:srgbClr val="6A7D80"/>
@@ -4238,6 +4185,7 @@
           <a:lstStyle xmlns:a="http://schemas.openxmlformats.org/drawingml/2006/main"/>
           <a:p xmlns:a="http://schemas.openxmlformats.org/drawingml/2006/main">
             <a:pPr algn="ctr">
+              <a:buNone/>
               <a:defRPr sz="1200" b="1">
                 <a:solidFill>
                   <a:srgbClr val="FFFFFF"/>
@@ -4288,6 +4236,7 @@
           <a:lstStyle xmlns:a="http://schemas.openxmlformats.org/drawingml/2006/main"/>
           <a:p xmlns:a="http://schemas.openxmlformats.org/drawingml/2006/main">
             <a:pPr algn="l">
+              <a:buNone/>
               <a:defRPr sz="1650" b="1">
                 <a:solidFill>
                   <a:srgbClr val="102C38"/>
@@ -4338,6 +4287,7 @@
           <a:lstStyle xmlns:a="http://schemas.openxmlformats.org/drawingml/2006/main"/>
           <a:p xmlns:a="http://schemas.openxmlformats.org/drawingml/2006/main">
             <a:pPr algn="l">
+              <a:buNone/>
               <a:defRPr sz="1125" b="0">
                 <a:solidFill>
                   <a:srgbClr val="6A7D80"/>
@@ -4419,6 +4369,7 @@
           <a:lstStyle xmlns:a="http://schemas.openxmlformats.org/drawingml/2006/main"/>
           <a:p xmlns:a="http://schemas.openxmlformats.org/drawingml/2006/main">
             <a:pPr algn="ctr">
+              <a:buNone/>
               <a:defRPr sz="1200" b="1">
                 <a:solidFill>
                   <a:srgbClr val="FFFFFF"/>
@@ -4469,6 +4420,7 @@
           <a:lstStyle xmlns:a="http://schemas.openxmlformats.org/drawingml/2006/main"/>
           <a:p xmlns:a="http://schemas.openxmlformats.org/drawingml/2006/main">
             <a:pPr algn="l">
+              <a:buNone/>
               <a:defRPr sz="1650" b="1">
                 <a:solidFill>
                   <a:srgbClr val="102C38"/>
@@ -4519,6 +4471,7 @@
           <a:lstStyle xmlns:a="http://schemas.openxmlformats.org/drawingml/2006/main"/>
           <a:p xmlns:a="http://schemas.openxmlformats.org/drawingml/2006/main">
             <a:pPr algn="l">
+              <a:buNone/>
               <a:defRPr sz="1125" b="0">
                 <a:solidFill>
                   <a:srgbClr val="6A7D80"/>
@@ -4635,6 +4588,7 @@
           <a:lstStyle xmlns:a="http://schemas.openxmlformats.org/drawingml/2006/main"/>
           <a:p xmlns:a="http://schemas.openxmlformats.org/drawingml/2006/main">
             <a:pPr algn="l">
+              <a:buNone/>
               <a:defRPr sz="2400" b="1">
                 <a:solidFill>
                   <a:srgbClr val="102C38"/>
@@ -4685,6 +4639,7 @@
           <a:lstStyle xmlns:a="http://schemas.openxmlformats.org/drawingml/2006/main"/>
           <a:p xmlns:a="http://schemas.openxmlformats.org/drawingml/2006/main">
             <a:pPr algn="l">
+              <a:buNone/>
               <a:defRPr sz="1125" b="0">
                 <a:solidFill>
                   <a:srgbClr val="6A7D80"/>
@@ -4801,6 +4756,7 @@
           <a:lstStyle xmlns:a="http://schemas.openxmlformats.org/drawingml/2006/main"/>
           <a:p xmlns:a="http://schemas.openxmlformats.org/drawingml/2006/main">
             <a:pPr algn="l">
+              <a:buNone/>
               <a:defRPr sz="2400" b="1">
                 <a:solidFill>
                   <a:srgbClr val="102C38"/>
@@ -4813,7 +4769,7 @@
                   <a:srgbClr val="102C38"/>
                 </a:solidFill>
               </a:rPr>
-              <a:t>28</a:t>
+              <a:t>80</a:t>
             </a:r>
           </a:p>
         </p:txBody>
@@ -4851,6 +4807,7 @@
           <a:lstStyle xmlns:a="http://schemas.openxmlformats.org/drawingml/2006/main"/>
           <a:p xmlns:a="http://schemas.openxmlformats.org/drawingml/2006/main">
             <a:pPr algn="l">
+              <a:buNone/>
               <a:defRPr sz="1125" b="0">
                 <a:solidFill>
                   <a:srgbClr val="6A7D80"/>
@@ -4967,6 +4924,7 @@
           <a:lstStyle xmlns:a="http://schemas.openxmlformats.org/drawingml/2006/main"/>
           <a:p xmlns:a="http://schemas.openxmlformats.org/drawingml/2006/main">
             <a:pPr algn="l">
+              <a:buNone/>
               <a:defRPr sz="2400" b="1">
                 <a:solidFill>
                   <a:srgbClr val="102C38"/>
@@ -5017,6 +4975,7 @@
           <a:lstStyle xmlns:a="http://schemas.openxmlformats.org/drawingml/2006/main"/>
           <a:p xmlns:a="http://schemas.openxmlformats.org/drawingml/2006/main">
             <a:pPr algn="l">
+              <a:buNone/>
               <a:defRPr sz="1125" b="0">
                 <a:solidFill>
                   <a:srgbClr val="6A7D80"/>
@@ -5133,6 +5092,7 @@
           <a:lstStyle xmlns:a="http://schemas.openxmlformats.org/drawingml/2006/main"/>
           <a:p xmlns:a="http://schemas.openxmlformats.org/drawingml/2006/main">
             <a:pPr algn="l">
+              <a:buNone/>
               <a:defRPr sz="2400" b="1">
                 <a:solidFill>
                   <a:srgbClr val="102C38"/>
@@ -5183,6 +5143,7 @@
           <a:lstStyle xmlns:a="http://schemas.openxmlformats.org/drawingml/2006/main"/>
           <a:p xmlns:a="http://schemas.openxmlformats.org/drawingml/2006/main">
             <a:pPr algn="l">
+              <a:buNone/>
               <a:defRPr sz="1125" b="0">
                 <a:solidFill>
                   <a:srgbClr val="6A7D80"/>
@@ -5262,6 +5223,7 @@
           <a:lstStyle xmlns:a="http://schemas.openxmlformats.org/drawingml/2006/main"/>
           <a:p xmlns:a="http://schemas.openxmlformats.org/drawingml/2006/main">
             <a:pPr algn="l">
+              <a:buNone/>
               <a:defRPr sz="975" b="1">
                 <a:solidFill>
                   <a:srgbClr val="C97936"/>
@@ -5312,6 +5274,7 @@
           <a:lstStyle xmlns:a="http://schemas.openxmlformats.org/drawingml/2006/main"/>
           <a:p xmlns:a="http://schemas.openxmlformats.org/drawingml/2006/main">
             <a:pPr algn="l">
+              <a:buNone/>
               <a:defRPr sz="3000" b="1">
                 <a:solidFill>
                   <a:srgbClr val="102C38"/>
@@ -5393,6 +5356,7 @@
           <a:lstStyle xmlns:a="http://schemas.openxmlformats.org/drawingml/2006/main"/>
           <a:p xmlns:a="http://schemas.openxmlformats.org/drawingml/2006/main">
             <a:pPr algn="l">
+              <a:buNone/>
               <a:defRPr sz="825" b="0">
                 <a:solidFill>
                   <a:srgbClr val="6A7D80"/>
@@ -5443,6 +5407,7 @@
           <a:lstStyle xmlns:a="http://schemas.openxmlformats.org/drawingml/2006/main"/>
           <a:p xmlns:a="http://schemas.openxmlformats.org/drawingml/2006/main">
             <a:pPr algn="r">
+              <a:buNone/>
               <a:defRPr sz="825" b="0">
                 <a:solidFill>
                   <a:srgbClr val="6A7D80"/>
@@ -5497,7 +5462,7 @@
       </p:sp>
       <p:graphicFrame>
         <p:nvGraphicFramePr>
-          <p:cNvPr id="22" name="Chart"/>
+          <p:cNvPr id="24" name="Chart"/>
           <p:cNvGraphicFramePr/>
           <p:nvPr/>
         </p:nvGraphicFramePr>
@@ -5507,7 +5472,7 @@
         </p:xfrm>
         <a:graphic xmlns:a="http://schemas.openxmlformats.org/drawingml/2006/main">
           <a:graphicData uri="http://schemas.openxmlformats.org/drawingml/2006/chart">
-            <c:chart xmlns:r="http://schemas.openxmlformats.org/officeDocument/2006/relationships" xmlns:c="http://schemas.openxmlformats.org/drawingml/2006/chart" r:id="Rcdbb32d4e1394ca0"/>
+            <c:chart xmlns:r="http://schemas.openxmlformats.org/officeDocument/2006/relationships" xmlns:c="http://schemas.openxmlformats.org/drawingml/2006/chart" r:id="Re4e4e8fc409a427f"/>
           </a:graphicData>
         </a:graphic>
       </p:graphicFrame>
@@ -5577,6 +5542,7 @@
           <a:lstStyle xmlns:a="http://schemas.openxmlformats.org/drawingml/2006/main"/>
           <a:p xmlns:a="http://schemas.openxmlformats.org/drawingml/2006/main">
             <a:pPr algn="ctr">
+              <a:buNone/>
               <a:defRPr sz="3600" b="1">
                 <a:solidFill>
                   <a:srgbClr val="FFFFFF"/>
@@ -5627,6 +5593,7 @@
           <a:lstStyle xmlns:a="http://schemas.openxmlformats.org/drawingml/2006/main"/>
           <a:p xmlns:a="http://schemas.openxmlformats.org/drawingml/2006/main">
             <a:pPr algn="ctr">
+              <a:buNone/>
               <a:defRPr sz="1425" b="0">
                 <a:solidFill>
                   <a:srgbClr val="DCEAE4"/>
@@ -5712,6 +5679,7 @@
           <a:lstStyle xmlns:a="http://schemas.openxmlformats.org/drawingml/2006/main"/>
           <a:p xmlns:a="http://schemas.openxmlformats.org/drawingml/2006/main">
             <a:pPr algn="ctr">
+              <a:buNone/>
               <a:defRPr sz="2850" b="1">
                 <a:solidFill>
                   <a:srgbClr val="102C38"/>
@@ -5762,6 +5730,7 @@
           <a:lstStyle xmlns:a="http://schemas.openxmlformats.org/drawingml/2006/main"/>
           <a:p xmlns:a="http://schemas.openxmlformats.org/drawingml/2006/main">
             <a:pPr algn="ctr">
+              <a:buNone/>
               <a:defRPr sz="1350" b="0">
                 <a:solidFill>
                   <a:srgbClr val="334B52"/>
@@ -5779,6 +5748,7 @@
           </a:p>
           <a:p xmlns:a="http://schemas.openxmlformats.org/drawingml/2006/main">
             <a:pPr algn="ctr">
+              <a:buNone/>
               <a:defRPr sz="1350" b="0">
                 <a:solidFill>
                   <a:srgbClr val="334B52"/>
@@ -5829,6 +5799,7 @@
           <a:lstStyle xmlns:a="http://schemas.openxmlformats.org/drawingml/2006/main"/>
           <a:p xmlns:a="http://schemas.openxmlformats.org/drawingml/2006/main">
             <a:pPr algn="l">
+              <a:buNone/>
               <a:defRPr sz="1125" b="1">
                 <a:solidFill>
                   <a:srgbClr val="3F756E"/>
@@ -5879,6 +5850,7 @@
           <a:lstStyle xmlns:a="http://schemas.openxmlformats.org/drawingml/2006/main"/>
           <a:p xmlns:a="http://schemas.openxmlformats.org/drawingml/2006/main">
             <a:pPr algn="r">
+              <a:buNone/>
               <a:defRPr sz="750" b="0">
                 <a:solidFill>
                   <a:srgbClr val="6A7D80"/>
@@ -5958,6 +5930,7 @@
           <a:lstStyle xmlns:a="http://schemas.openxmlformats.org/drawingml/2006/main"/>
           <a:p xmlns:a="http://schemas.openxmlformats.org/drawingml/2006/main">
             <a:pPr algn="l">
+              <a:buNone/>
               <a:defRPr sz="975" b="1">
                 <a:solidFill>
                   <a:srgbClr val="F0B35E"/>
@@ -6008,6 +5981,7 @@
           <a:lstStyle xmlns:a="http://schemas.openxmlformats.org/drawingml/2006/main"/>
           <a:p xmlns:a="http://schemas.openxmlformats.org/drawingml/2006/main">
             <a:pPr algn="l">
+              <a:buNone/>
               <a:defRPr sz="3525" b="1">
                 <a:solidFill>
                   <a:srgbClr val="FFFFFF"/>
@@ -6025,6 +5999,7 @@
           </a:p>
           <a:p xmlns:a="http://schemas.openxmlformats.org/drawingml/2006/main">
             <a:pPr algn="l">
+              <a:buNone/>
               <a:defRPr sz="3525" b="1">
                 <a:solidFill>
                   <a:srgbClr val="FFFFFF"/>
@@ -6141,6 +6116,7 @@
           <a:lstStyle xmlns:a="http://schemas.openxmlformats.org/drawingml/2006/main"/>
           <a:p xmlns:a="http://schemas.openxmlformats.org/drawingml/2006/main">
             <a:pPr algn="l">
+              <a:buNone/>
               <a:defRPr sz="2400" b="1">
                 <a:solidFill>
                   <a:srgbClr val="102C38"/>
@@ -6191,6 +6167,7 @@
           <a:lstStyle xmlns:a="http://schemas.openxmlformats.org/drawingml/2006/main"/>
           <a:p xmlns:a="http://schemas.openxmlformats.org/drawingml/2006/main">
             <a:pPr algn="l">
+              <a:buNone/>
               <a:defRPr sz="1125" b="0">
                 <a:solidFill>
                   <a:srgbClr val="6A7D80"/>
@@ -6307,6 +6284,7 @@
           <a:lstStyle xmlns:a="http://schemas.openxmlformats.org/drawingml/2006/main"/>
           <a:p xmlns:a="http://schemas.openxmlformats.org/drawingml/2006/main">
             <a:pPr algn="l">
+              <a:buNone/>
               <a:defRPr sz="2400" b="1">
                 <a:solidFill>
                   <a:srgbClr val="102C38"/>
@@ -6357,6 +6335,7 @@
           <a:lstStyle xmlns:a="http://schemas.openxmlformats.org/drawingml/2006/main"/>
           <a:p xmlns:a="http://schemas.openxmlformats.org/drawingml/2006/main">
             <a:pPr algn="l">
+              <a:buNone/>
               <a:defRPr sz="1125" b="0">
                 <a:solidFill>
                   <a:srgbClr val="6A7D80"/>
@@ -6473,6 +6452,7 @@
           <a:lstStyle xmlns:a="http://schemas.openxmlformats.org/drawingml/2006/main"/>
           <a:p xmlns:a="http://schemas.openxmlformats.org/drawingml/2006/main">
             <a:pPr algn="l">
+              <a:buNone/>
               <a:defRPr sz="2400" b="1">
                 <a:solidFill>
                   <a:srgbClr val="102C38"/>
@@ -6523,6 +6503,7 @@
           <a:lstStyle xmlns:a="http://schemas.openxmlformats.org/drawingml/2006/main"/>
           <a:p xmlns:a="http://schemas.openxmlformats.org/drawingml/2006/main">
             <a:pPr algn="l">
+              <a:buNone/>
               <a:defRPr sz="1125" b="0">
                 <a:solidFill>
                   <a:srgbClr val="6A7D80"/>
@@ -6639,6 +6620,7 @@
           <a:lstStyle xmlns:a="http://schemas.openxmlformats.org/drawingml/2006/main"/>
           <a:p xmlns:a="http://schemas.openxmlformats.org/drawingml/2006/main">
             <a:pPr algn="l">
+              <a:buNone/>
               <a:defRPr sz="2400" b="1">
                 <a:solidFill>
                   <a:srgbClr val="102C38"/>
@@ -6689,6 +6671,7 @@
           <a:lstStyle xmlns:a="http://schemas.openxmlformats.org/drawingml/2006/main"/>
           <a:p xmlns:a="http://schemas.openxmlformats.org/drawingml/2006/main">
             <a:pPr algn="l">
+              <a:buNone/>
               <a:defRPr sz="1125" b="0">
                 <a:solidFill>
                   <a:srgbClr val="6A7D80"/>
@@ -6739,6 +6722,7 @@
           <a:lstStyle xmlns:a="http://schemas.openxmlformats.org/drawingml/2006/main"/>
           <a:p xmlns:a="http://schemas.openxmlformats.org/drawingml/2006/main">
             <a:pPr algn="l">
+              <a:buNone/>
               <a:defRPr sz="1500" b="1">
                 <a:solidFill>
                   <a:srgbClr val="DCEAE4"/>
@@ -6789,6 +6773,7 @@
           <a:lstStyle xmlns:a="http://schemas.openxmlformats.org/drawingml/2006/main"/>
           <a:p xmlns:a="http://schemas.openxmlformats.org/drawingml/2006/main">
             <a:pPr algn="l">
+              <a:buNone/>
               <a:defRPr sz="1275" b="0">
                 <a:solidFill>
                   <a:srgbClr val="BFD6D0"/>
@@ -6872,6 +6857,7 @@
           <a:lstStyle xmlns:a="http://schemas.openxmlformats.org/drawingml/2006/main"/>
           <a:p xmlns:a="http://schemas.openxmlformats.org/drawingml/2006/main">
             <a:pPr algn="l">
+              <a:buNone/>
               <a:defRPr sz="1425" b="1">
                 <a:solidFill>
                   <a:srgbClr val="102C38"/>
@@ -6922,6 +6908,7 @@
           <a:lstStyle xmlns:a="http://schemas.openxmlformats.org/drawingml/2006/main"/>
           <a:p xmlns:a="http://schemas.openxmlformats.org/drawingml/2006/main">
             <a:pPr algn="r">
+              <a:buNone/>
               <a:defRPr sz="1575" b="1">
                 <a:solidFill>
                   <a:srgbClr val="FFFFFF"/>

</xml_diff>

<commit_message>
release: prepare SignalForge v1.1.1 championship candidate
</commit_message>
<xml_diff>
--- a/output/presentation/SignalForge-Judge-Deck.pptx
+++ b/output/presentation/SignalForge-Judge-Deck.pptx
@@ -2,18 +2,18 @@
 <file path=ppt/presentation.xml><?xml version="1.0" encoding="utf-8"?>
 <p:presentation xmlns:p="http://schemas.openxmlformats.org/presentationml/2006/main">
   <p:sldMasterIdLst>
-    <p:sldMasterId xmlns:r="http://schemas.openxmlformats.org/officeDocument/2006/relationships" id="2147483648" r:id="R019c2f26a75247cb"/>
+    <p:sldMasterId xmlns:r="http://schemas.openxmlformats.org/officeDocument/2006/relationships" id="2147483648" r:id="R8f7e4ccf094d4c21"/>
   </p:sldMasterIdLst>
   <p:notesMasterIdLst>
-    <p:notesMasterId xmlns:r="http://schemas.openxmlformats.org/officeDocument/2006/relationships" r:id="Raef91185217a4883"/>
+    <p:notesMasterId xmlns:r="http://schemas.openxmlformats.org/officeDocument/2006/relationships" r:id="R2db1c3fa81cd4ee1"/>
   </p:notesMasterIdLst>
   <p:sldIdLst>
-    <p:sldId xmlns:r="http://schemas.openxmlformats.org/officeDocument/2006/relationships" id="256" r:id="R175dca391be34a98"/>
-    <p:sldId xmlns:r="http://schemas.openxmlformats.org/officeDocument/2006/relationships" id="257" r:id="R1b01041426ff42bb"/>
-    <p:sldId xmlns:r="http://schemas.openxmlformats.org/officeDocument/2006/relationships" id="258" r:id="R0bc27265310446ef"/>
-    <p:sldId xmlns:r="http://schemas.openxmlformats.org/officeDocument/2006/relationships" id="259" r:id="Re51853a91cab497c"/>
-    <p:sldId xmlns:r="http://schemas.openxmlformats.org/officeDocument/2006/relationships" id="260" r:id="R7696d42331e940ca"/>
-    <p:sldId xmlns:r="http://schemas.openxmlformats.org/officeDocument/2006/relationships" id="261" r:id="Re11337ac353e4e1a"/>
+    <p:sldId xmlns:r="http://schemas.openxmlformats.org/officeDocument/2006/relationships" id="256" r:id="Rde6424f8bba44e91"/>
+    <p:sldId xmlns:r="http://schemas.openxmlformats.org/officeDocument/2006/relationships" id="257" r:id="Rae7c5ef61d504ccc"/>
+    <p:sldId xmlns:r="http://schemas.openxmlformats.org/officeDocument/2006/relationships" id="258" r:id="Rab7c262cb13a4839"/>
+    <p:sldId xmlns:r="http://schemas.openxmlformats.org/officeDocument/2006/relationships" id="259" r:id="Rc419c20afa5f4f4a"/>
+    <p:sldId xmlns:r="http://schemas.openxmlformats.org/officeDocument/2006/relationships" id="260" r:id="R6e973d8775874bd8"/>
+    <p:sldId xmlns:r="http://schemas.openxmlformats.org/officeDocument/2006/relationships" id="261" r:id="R8c01879832be4db5"/>
   </p:sldIdLst>
   <p:sldSz cx="12192000" cy="6858000"/>
   <p:notesSz cx="6858000" cy="9144000"/>
@@ -577,7 +577,36 @@
         <p:txBody>
           <a:bodyPr xmlns:a="http://schemas.openxmlformats.org/drawingml/2006/main"/>
           <a:lstStyle xmlns:a="http://schemas.openxmlformats.org/drawingml/2006/main"/>
-          <a:p xmlns:a="http://schemas.openxmlformats.org/drawingml/2006/main"/>
+          <a:p xmlns:a="http://schemas.openxmlformats.org/drawingml/2006/main">
+            <a:r>
+              <a:t>Explain the authority boundary: local Gemma owns review and synthesis; optional Radeon API specialists contribute bounded context; deterministic Go engines own calculations and release policy.</a:t>
+            </a:r>
+          </a:p>
+          <a:p xmlns:a="http://schemas.openxmlformats.org/drawingml/2006/main">
+            <a:r>
+              <a:t>[Sources]</a:t>
+            </a:r>
+          </a:p>
+          <a:p xmlns:a="http://schemas.openxmlformats.org/drawingml/2006/main">
+            <a:r>
+              <a:t>- docs/architecture.svg</a:t>
+            </a:r>
+          </a:p>
+          <a:p xmlns:a="http://schemas.openxmlformats.org/drawingml/2006/main">
+            <a:r>
+              <a:t>- docs/track2-compliance.md</a:t>
+            </a:r>
+          </a:p>
+          <a:p xmlns:a="http://schemas.openxmlformats.org/drawingml/2006/main">
+            <a:r>
+              <a:t>- evidence/sprint36-radeon-hybrid-journey.json</a:t>
+            </a:r>
+          </a:p>
+          <a:p xmlns:a="http://schemas.openxmlformats.org/drawingml/2006/main">
+            <a:r>
+              <a:t>[/Sources]</a:t>
+            </a:r>
+          </a:p>
         </p:txBody>
       </p:sp>
       <p:sp>
@@ -709,7 +738,31 @@
         <p:txBody>
           <a:bodyPr xmlns:a="http://schemas.openxmlformats.org/drawingml/2006/main"/>
           <a:lstStyle xmlns:a="http://schemas.openxmlformats.org/drawingml/2006/main"/>
-          <a:p xmlns:a="http://schemas.openxmlformats.org/drawingml/2006/main"/>
+          <a:p xmlns:a="http://schemas.openxmlformats.org/drawingml/2006/main">
+            <a:r>
+              <a:t>This is a bounded development tournament, not a universal benchmark. Each compared mode contains eight public non-sealed journeys using the same Gemma 4 26B A4B QAT Q4_0 model class.</a:t>
+            </a:r>
+          </a:p>
+          <a:p xmlns:a="http://schemas.openxmlformats.org/drawingml/2006/main">
+            <a:r>
+              <a:t>[Sources]</a:t>
+            </a:r>
+          </a:p>
+          <a:p xmlns:a="http://schemas.openxmlformats.org/drawingml/2006/main">
+            <a:r>
+              <a:t>- evidence/sprint33-latency-tournament.json</a:t>
+            </a:r>
+          </a:p>
+          <a:p xmlns:a="http://schemas.openxmlformats.org/drawingml/2006/main">
+            <a:r>
+              <a:t>- evidence/public-claims.json</a:t>
+            </a:r>
+          </a:p>
+          <a:p xmlns:a="http://schemas.openxmlformats.org/drawingml/2006/main">
+            <a:r>
+              <a:t>[/Sources]</a:t>
+            </a:r>
+          </a:p>
         </p:txBody>
       </p:sp>
       <p:sp>
@@ -775,7 +828,36 @@
         <p:txBody>
           <a:bodyPr xmlns:a="http://schemas.openxmlformats.org/drawingml/2006/main"/>
           <a:lstStyle xmlns:a="http://schemas.openxmlformats.org/drawingml/2006/main"/>
-          <a:p xmlns:a="http://schemas.openxmlformats.org/drawingml/2006/main"/>
+          <a:p xmlns:a="http://schemas.openxmlformats.org/drawingml/2006/main">
+            <a:r>
+              <a:t>Close on verifiability: exact public artifacts demonstrate contract preservation, local recovery from Radeon API loss, and zero released answers when the local model is unavailable.</a:t>
+            </a:r>
+          </a:p>
+          <a:p xmlns:a="http://schemas.openxmlformats.org/drawingml/2006/main">
+            <a:r>
+              <a:t>[Sources]</a:t>
+            </a:r>
+          </a:p>
+          <a:p xmlns:a="http://schemas.openxmlformats.org/drawingml/2006/main">
+            <a:r>
+              <a:t>- evidence/sprint36-radeon-resilience.json</a:t>
+            </a:r>
+          </a:p>
+          <a:p xmlns:a="http://schemas.openxmlformats.org/drawingml/2006/main">
+            <a:r>
+              <a:t>- evidence/sprint36-radeon-local-journey.json</a:t>
+            </a:r>
+          </a:p>
+          <a:p xmlns:a="http://schemas.openxmlformats.org/drawingml/2006/main">
+            <a:r>
+              <a:t>- evidence/sprint36-radeon-hybrid-journey.json</a:t>
+            </a:r>
+          </a:p>
+          <a:p xmlns:a="http://schemas.openxmlformats.org/drawingml/2006/main">
+            <a:r>
+              <a:t>[/Sources]</a:t>
+            </a:r>
+          </a:p>
         </p:txBody>
       </p:sp>
       <p:sp>
@@ -841,7 +923,7 @@
   </p:cSld>
   <p:clrMap bg1="lt1" tx1="dk1" bg2="lt2" tx2="dk2" accent1="accent1" accent2="accent2" accent3="accent3" accent4="accent4" accent5="accent5" accent6="accent6" hlink="hlink" folHlink="folHlink"/>
   <p:sldLayoutIdLst>
-    <p:sldLayoutId xmlns:r="http://schemas.openxmlformats.org/officeDocument/2006/relationships" id="2147483649" r:id="Rbc681ff179a6495d"/>
+    <p:sldLayoutId xmlns:r="http://schemas.openxmlformats.org/officeDocument/2006/relationships" id="2147483649" r:id="R18b2f387a7aa429d"/>
   </p:sldLayoutIdLst>
   <p:txStyles>
     <p:titleStyle>
@@ -1389,24 +1471,30 @@
           </c:spPr>
           <c:cat>
             <c:strLit>
-              <c:ptCount val="2"/>
+              <c:ptCount val="3"/>
               <c:pt idx="0">
-                <c:v>Three context workers</c:v>
+                <c:v>Baseline · 2 workers</c:v>
               </c:pt>
               <c:pt idx="1">
-                <c:v>Four context workers</c:v>
+                <c:v>Local · 4 workers</c:v>
+              </c:pt>
+              <c:pt idx="2">
+                <c:v>Hybrid · 4 workers</c:v>
               </c:pt>
             </c:strLit>
           </c:cat>
           <c:val>
             <c:numLit>
               <c:formatCode>General</c:formatCode>
-              <c:ptCount val="2"/>
+              <c:ptCount val="3"/>
               <c:pt idx="0">
-                <c:v>222.31</c:v>
+                <c:v>118.918</c:v>
               </c:pt>
               <c:pt idx="1">
-                <c:v>157.47</c:v>
+                <c:v>42.376</c:v>
+              </c:pt>
+              <c:pt idx="2">
+                <c:v>50.585</c:v>
               </c:pt>
             </c:numLit>
           </c:val>
@@ -1892,7 +1980,7 @@
                   <a:srgbClr val="102C38"/>
                 </a:solidFill>
               </a:rPr>
-              <a:t>No remote inference</a:t>
+              <a:t>Local core + optional</a:t>
             </a:r>
           </a:p>
           <a:p xmlns:a="http://schemas.openxmlformats.org/drawingml/2006/main">
@@ -1910,7 +1998,7 @@
                   <a:srgbClr val="102C38"/>
                 </a:solidFill>
               </a:rPr>
-              <a:t>in the accepted golden path</a:t>
+              <a:t>Radeon API specialists</a:t>
             </a:r>
           </a:p>
         </p:txBody>
@@ -3241,11 +3329,11 @@
           <p:nvPr/>
         </p:nvPicPr>
         <p:blipFill>
-          <a:blip xmlns:r="http://schemas.openxmlformats.org/officeDocument/2006/relationships" xmlns:a="http://schemas.openxmlformats.org/drawingml/2006/main" r:embed="Rd9d3ebfa54434e08"/>
+          <a:blip xmlns:r="http://schemas.openxmlformats.org/officeDocument/2006/relationships" xmlns:a="http://schemas.openxmlformats.org/drawingml/2006/main" r:embed="Re38d965685b14488"/>
           <a:stretch xmlns:a="http://schemas.openxmlformats.org/drawingml/2006/main"/>
         </p:blipFill>
         <p:spPr>
-          <a:xfrm xmlns:a="http://schemas.openxmlformats.org/drawingml/2006/main">
+          <a:xfrm xmlns:a="http://schemas.openxmlformats.org/drawingml/2006/main" flipH="0" flipV="0">
             <a:off x="2499360" y="1504950"/>
             <a:ext cx="7193280" cy="4495800"/>
           </a:xfrm>
@@ -3300,7 +3388,7 @@
                   <a:srgbClr val="3F756E"/>
                 </a:solidFill>
               </a:rPr>
-              <a:t>One local model runtime supports specialist roles; Go controls values, tools, evidence, lineage, and publication.</a:t>
+              <a:t>Local Gemma reviews and synthesizes; optional Radeon API specialists add bounded context; Go owns values, tools, evidence, lineage, and release.</a:t>
             </a:r>
           </a:p>
         </p:txBody>
@@ -5287,7 +5375,7 @@
                   <a:srgbClr val="102C38"/>
                 </a:solidFill>
               </a:rPr>
-              <a:t>The complete journey became faster without weakening the gate</a:t>
+              <a:t>Four workers cut p50 by 64.37% without weakening the gate</a:t>
             </a:r>
           </a:p>
         </p:txBody>
@@ -5472,7 +5560,7 @@
         </p:xfrm>
         <a:graphic xmlns:a="http://schemas.openxmlformats.org/drawingml/2006/main">
           <a:graphicData uri="http://schemas.openxmlformats.org/drawingml/2006/chart">
-            <c:chart xmlns:r="http://schemas.openxmlformats.org/officeDocument/2006/relationships" xmlns:c="http://schemas.openxmlformats.org/drawingml/2006/chart" r:id="Re4e4e8fc409a427f"/>
+            <c:chart xmlns:r="http://schemas.openxmlformats.org/officeDocument/2006/relationships" xmlns:c="http://schemas.openxmlformats.org/drawingml/2006/chart" r:id="R7f9d4b3295674c86"/>
           </a:graphicData>
         </a:graphic>
       </p:graphicFrame>
@@ -5555,7 +5643,7 @@
                   <a:srgbClr val="FFFFFF"/>
                 </a:solidFill>
               </a:rPr>
-              <a:t>29.17%</a:t>
+              <a:t>2.78×</a:t>
             </a:r>
           </a:p>
         </p:txBody>
@@ -5606,7 +5694,7 @@
                   <a:srgbClr val="DCEAE4"/>
                 </a:solidFill>
               </a:rPr>
-              <a:t>faster end to end</a:t>
+              <a:t>aggregate local4 speedup</a:t>
             </a:r>
           </a:p>
         </p:txBody>
@@ -5692,7 +5780,7 @@
                   <a:srgbClr val="102C38"/>
                 </a:solidFill>
               </a:rPr>
-              <a:t>44 / 44</a:t>
+              <a:t>8 / 8</a:t>
             </a:r>
           </a:p>
         </p:txBody>
@@ -5743,7 +5831,7 @@
                   <a:srgbClr val="334B52"/>
                 </a:solidFill>
               </a:rPr>
-              <a:t>frozen semantic checks</a:t>
+              <a:t>contracts passed in each</a:t>
             </a:r>
           </a:p>
           <a:p xmlns:a="http://schemas.openxmlformats.org/drawingml/2006/main">
@@ -5761,7 +5849,7 @@
                   <a:srgbClr val="334B52"/>
                 </a:solidFill>
               </a:rPr>
-              <a:t>passed by both profiles</a:t>
+              <a:t>public development mode</a:t>
             </a:r>
           </a:p>
         </p:txBody>
@@ -5812,7 +5900,7 @@
                   <a:srgbClr val="3F756E"/>
                 </a:solidFill>
               </a:rPr>
-              <a:t>Unified F16 KV also restored 32,768-token request capacity: 70/80 → 80/80 contract observations.</a:t>
+              <a:t>Hybrid4 also achieved 2.08× aggregate speedup with 20 accepted Radeon API calls and one locally recovered remote failure.</a:t>
             </a:r>
           </a:p>
         </p:txBody>
@@ -5863,7 +5951,7 @@
                   <a:srgbClr val="6A7D80"/>
                 </a:solidFill>
               </a:rPr>
-              <a:t>Source: evidence/radeon-optimization.json</a:t>
+              <a:t>Source: evidence/sprint33-latency-tournament.json</a:t>
             </a:r>
           </a:p>
         </p:txBody>
@@ -6129,7 +6217,7 @@
                   <a:srgbClr val="102C38"/>
                 </a:solidFill>
               </a:rPr>
-              <a:t>26</a:t>
+              <a:t>8/8</a:t>
             </a:r>
           </a:p>
         </p:txBody>
@@ -6180,7 +6268,7 @@
                   <a:srgbClr val="6A7D80"/>
                 </a:solidFill>
               </a:rPr>
-              <a:t>adversarial cases</a:t>
+              <a:t>local4 contracts</a:t>
             </a:r>
           </a:p>
         </p:txBody>
@@ -6297,7 +6385,7 @@
                   <a:srgbClr val="102C38"/>
                 </a:solidFill>
               </a:rPr>
-              <a:t>11</a:t>
+              <a:t>8/8</a:t>
             </a:r>
           </a:p>
         </p:txBody>
@@ -6348,7 +6436,7 @@
                   <a:srgbClr val="6A7D80"/>
                 </a:solidFill>
               </a:rPr>
-              <a:t>executable gates</a:t>
+              <a:t>hybrid4 contracts</a:t>
             </a:r>
           </a:p>
         </p:txBody>
@@ -6465,7 +6553,7 @@
                   <a:srgbClr val="102C38"/>
                 </a:solidFill>
               </a:rPr>
-              <a:t>22</a:t>
+              <a:t>1</a:t>
             </a:r>
           </a:p>
         </p:txBody>
@@ -6516,7 +6604,7 @@
                   <a:srgbClr val="6A7D80"/>
                 </a:solidFill>
               </a:rPr>
-              <a:t>critical threats</a:t>
+              <a:t>API loss recovered</a:t>
             </a:r>
           </a:p>
         </p:txBody>
@@ -6684,7 +6772,7 @@
                   <a:srgbClr val="6A7D80"/>
                 </a:solidFill>
               </a:rPr>
-              <a:t>current release blockers</a:t>
+              <a:t>answers on model loss</a:t>
             </a:r>
           </a:p>
         </p:txBody>
@@ -6735,7 +6823,7 @@
                   <a:srgbClr val="DCEAE4"/>
                 </a:solidFill>
               </a:rPr>
-              <a:t>Primary evidence · deterministic receipts · independent review · explicit residual risk</a:t>
+              <a:t>Primary evidence · deterministic receipts · independent review · explicit fail-closed release</a:t>
             </a:r>
           </a:p>
         </p:txBody>
@@ -6786,7 +6874,7 @@
                   <a:srgbClr val="BFD6D0"/>
                 </a:solidFill>
               </a:rPr>
-              <a:t>Bounded to Microsoft and NVIDIA. External human-ground-truth accuracy remains unscored. Novel injection and plausible upstream data errors still require review.</a:t>
+              <a:t>Bounded, non-sealed development evidence; no universal accuracy or throughput claim.</a:t>
             </a:r>
           </a:p>
         </p:txBody>

</xml_diff>